<commit_message>
Update slides for new model
</commit_message>
<xml_diff>
--- a/slides.pptx
+++ b/slides.pptx
@@ -7671,7 +7671,7 @@
             </a:pPr>
             <a:r>
               <a:rPr lang="en"/>
-              <a:t>L’F1-Score mostra un miglioramento del 15% rispetto alla support vector machine utilizzata nell’Assignment 2.</a:t>
+              <a:t>L’F1-Score mostra un miglioramento del 18% rispetto alla support vector machine utilizzata nell’Assignment 2.</a:t>
             </a:r>
             <a:endParaRPr/>
           </a:p>
@@ -7719,7 +7719,7 @@
             <a:tbl>
               <a:tblPr>
                 <a:noFill/>
-                <a:tableStyleId>{CD3E96D9-E143-4625-B8E8-AB0AB3C41494}</a:tableStyleId>
+                <a:tableStyleId>{BA8DF622-62CD-4A15-923E-5C4DD602BB09}</a:tableStyleId>
               </a:tblPr>
               <a:tblGrid>
                 <a:gridCol w="1432900"/>
@@ -8039,7 +8039,7 @@
         </p:spPr>
         <p:txBody>
           <a:bodyPr anchorCtr="0" anchor="t" bIns="91425" lIns="91425" spcFirstLastPara="1" rIns="91425" wrap="square" tIns="91425">
-            <a:normAutofit fontScale="70000" lnSpcReduction="10000"/>
+            <a:normAutofit fontScale="62500" lnSpcReduction="20000"/>
           </a:bodyPr>
           <a:lstStyle/>
           <a:p>
@@ -8070,7 +8070,15 @@
             </a:r>
             <a:r>
               <a:rPr lang="en"/>
-              <a:t> è una delle più comuni. Ne è un esempio l’immagine in alto a sinistra, la cui classe reale è </a:t>
+              <a:t> è una delle più comuni. Ne è un esempio l’immagine </a:t>
+            </a:r>
+            <a:r>
+              <a:rPr lang="en"/>
+              <a:t>del test set </a:t>
+            </a:r>
+            <a:r>
+              <a:rPr lang="en"/>
+              <a:t>in alto a sinistra, la cui classe reale è </a:t>
             </a:r>
             <a:r>
               <a:rPr i="1" lang="en"/>
@@ -8106,11 +8114,43 @@
             </a:r>
             <a:r>
               <a:rPr i="1" lang="en"/>
+              <a:t>denseresidential</a:t>
+            </a:r>
+            <a:r>
+              <a:rPr lang="en"/>
+              <a:t> con una probabilità del 57%. Seguono le classi </a:t>
+            </a:r>
+            <a:r>
+              <a:rPr i="1" lang="en"/>
+              <a:t>mediumresidential</a:t>
+            </a:r>
+            <a:r>
+              <a:rPr lang="en"/>
+              <a:t> (12%), </a:t>
+            </a:r>
+            <a:r>
+              <a:rPr i="1" lang="en"/>
               <a:t>intersection</a:t>
             </a:r>
             <a:r>
               <a:rPr lang="en"/>
-              <a:t>.</a:t>
+              <a:t> (7%), </a:t>
+            </a:r>
+            <a:r>
+              <a:rPr i="1" lang="en"/>
+              <a:t>buildings</a:t>
+            </a:r>
+            <a:r>
+              <a:rPr lang="en"/>
+              <a:t> (6%) e </a:t>
+            </a:r>
+            <a:r>
+              <a:rPr i="1" lang="en"/>
+              <a:t>tenniscourt</a:t>
+            </a:r>
+            <a:r>
+              <a:rPr lang="en"/>
+              <a:t> (5%).</a:t>
             </a:r>
             <a:endParaRPr/>
           </a:p>
@@ -8120,7 +8160,7 @@
                 <a:spcPts val="1200"/>
               </a:spcBef>
               <a:spcAft>
-                <a:spcPts val="1200"/>
+                <a:spcPts val="0"/>
               </a:spcAft>
               <a:buNone/>
             </a:pPr>
@@ -8134,7 +8174,23 @@
             </a:r>
             <a:r>
               <a:rPr lang="en"/>
-              <a:t>con una probabilità pari al 96% nonostante siano presenti molti elementi di disturbo. Analogamente, l’immagine in basso a destra viene classificata correttamente come </a:t>
+              <a:t>con una probabilità pari all’80% nonostante siano presenti molti elementi di disturbo.</a:t>
+            </a:r>
+            <a:endParaRPr/>
+          </a:p>
+          <a:p>
+            <a:pPr indent="0" lvl="0" marL="0" rtl="0" algn="just">
+              <a:spcBef>
+                <a:spcPts val="1200"/>
+              </a:spcBef>
+              <a:spcAft>
+                <a:spcPts val="1200"/>
+              </a:spcAft>
+              <a:buNone/>
+            </a:pPr>
+            <a:r>
+              <a:rPr lang="en"/>
+              <a:t>Analogamente, l’immagine in basso a destra viene classificata correttamente come </a:t>
             </a:r>
             <a:r>
               <a:rPr i="1" lang="en"/>
@@ -8142,7 +8198,7 @@
             </a:r>
             <a:r>
               <a:rPr lang="en"/>
-              <a:t> con una probabilità pari al 99%, tuttavia quest’ultima faceva parte del training set.</a:t>
+              <a:t> con una probabilità pari al 99%, tuttavia quest’ultima faceva parte del training set. La presenza del campo da tennis fa sorgere dei dubbi sul sovradattamento.</a:t>
             </a:r>
             <a:endParaRPr/>
           </a:p>
@@ -8164,7 +8220,7 @@
         </p:blipFill>
         <p:spPr>
           <a:xfrm>
-            <a:off x="0" y="0"/>
+            <a:off x="7033175" y="0"/>
             <a:ext cx="2110825" cy="2110825"/>
           </a:xfrm>
           <a:prstGeom prst="rect">
@@ -8192,7 +8248,7 @@
         </p:blipFill>
         <p:spPr>
           <a:xfrm>
-            <a:off x="7033175" y="0"/>
+            <a:off x="7033175" y="3032675"/>
             <a:ext cx="2110825" cy="2110825"/>
           </a:xfrm>
           <a:prstGeom prst="rect">
@@ -8206,7 +8262,7 @@
       </p:pic>
       <p:pic>
         <p:nvPicPr>
-          <p:cNvPr id="147" name="Google Shape;147;p25"/>
+          <p:cNvPr id="147" name="Google Shape;147;p25" title="mediumresidential09.jpg"/>
           <p:cNvPicPr preferRelativeResize="0"/>
           <p:nvPr/>
         </p:nvPicPr>
@@ -8220,7 +8276,7 @@
         </p:blipFill>
         <p:spPr>
           <a:xfrm>
-            <a:off x="0" y="3032675"/>
+            <a:off x="0" y="0"/>
             <a:ext cx="2110825" cy="2110825"/>
           </a:xfrm>
           <a:prstGeom prst="rect">
@@ -8234,7 +8290,7 @@
       </p:pic>
       <p:pic>
         <p:nvPicPr>
-          <p:cNvPr id="148" name="Google Shape;148;p25"/>
+          <p:cNvPr id="148" name="Google Shape;148;p25" title="tenniscourt46.jpg"/>
           <p:cNvPicPr preferRelativeResize="0"/>
           <p:nvPr/>
         </p:nvPicPr>
@@ -8248,7 +8304,7 @@
         </p:blipFill>
         <p:spPr>
           <a:xfrm>
-            <a:off x="7033175" y="3032675"/>
+            <a:off x="0" y="3032675"/>
             <a:ext cx="2110825" cy="2110825"/>
           </a:xfrm>
           <a:prstGeom prst="rect">
@@ -8379,7 +8435,7 @@
             </a:pPr>
             <a:r>
               <a:rPr lang="en"/>
-              <a:t>La classificazione multi-classe forza il modello a scegliere un'unica etichetta, ignorando il fatto che un'immagine aerea contiene spesso più elementi. Questo crea ambiguità sia per il modello in fase di addestramento, sia nella valutazione dei casi d'errore. Ne è un esempio l’immagine riportata in basso a destra in una slide precedente. Una possibile soluzione consiste nell’utilizzo di un dataset in cui a ogni immagine sono associate più classi.</a:t>
+              <a:t>La classificazione multi-classe forza il modello a scegliere un'unica etichetta, ignorando il fatto che un'immagine aerea contiene spesso più elementi. Questo crea ambiguità sia per il modello in fase di addestramento, sia nella valutazione dei casi d'errore. Ne è un esempio l’immagine riportata in basso a destra nella slide precedente. Una possibile soluzione consiste nell’utilizzo di un dataset in cui a ogni immagine sono associate più classi.</a:t>
             </a:r>
             <a:endParaRPr/>
           </a:p>
@@ -10424,7 +10480,7 @@
             <a:tbl>
               <a:tblPr>
                 <a:noFill/>
-                <a:tableStyleId>{CD3E96D9-E143-4625-B8E8-AB0AB3C41494}</a:tableStyleId>
+                <a:tableStyleId>{BA8DF622-62CD-4A15-923E-5C4DD602BB09}</a:tableStyleId>
               </a:tblPr>
               <a:tblGrid>
                 <a:gridCol w="1670800"/>

</xml_diff>